<commit_message>
chore: update PPT template in _data
</commit_message>
<xml_diff>
--- a/_data/PSC/PSC_PPT_Template.pptx
+++ b/_data/PSC/PSC_PPT_Template.pptx
@@ -5,13 +5,15 @@
     <p:sldMasterId id="2147483648" r:id="rId1"/>
   </p:sldMasterIdLst>
   <p:notesMasterIdLst>
-    <p:notesMasterId r:id="rId3"/>
+    <p:notesMasterId r:id="rId5"/>
   </p:notesMasterIdLst>
   <p:handoutMasterIdLst>
-    <p:handoutMasterId r:id="rId4"/>
+    <p:handoutMasterId r:id="rId6"/>
   </p:handoutMasterIdLst>
   <p:sldIdLst>
-    <p:sldId id="685" r:id="rId2"/>
+    <p:sldId id="687" r:id="rId2"/>
+    <p:sldId id="685" r:id="rId3"/>
+    <p:sldId id="688" r:id="rId4"/>
   </p:sldIdLst>
   <p:sldSz cx="9144000" cy="5143500" type="screen16x9"/>
   <p:notesSz cx="6858000" cy="9144000"/>
@@ -112,7 +114,7 @@
   </p:defaultTextStyle>
   <p:extLst>
     <p:ext uri="{EFAFB233-063F-42B5-8137-9DF3F51BA10A}">
-      <p15:sldGuideLst xmlns:p15="http://schemas.microsoft.com/office/powerpoint/2012/main" xmlns="">
+      <p15:sldGuideLst xmlns="" xmlns:p15="http://schemas.microsoft.com/office/powerpoint/2012/main">
         <p15:guide id="1" orient="horz" pos="2160">
           <p15:clr>
             <a:srgbClr val="A4A3A4"/>
@@ -136,7 +138,7 @@
       </p15:sldGuideLst>
     </p:ext>
     <p:ext uri="{2D200454-40CA-4A62-9FC3-DE9A4176ACB9}">
-      <p15:notesGuideLst xmlns:p15="http://schemas.microsoft.com/office/powerpoint/2012/main" xmlns=""/>
+      <p15:notesGuideLst xmlns="" xmlns:p15="http://schemas.microsoft.com/office/powerpoint/2012/main"/>
     </p:ext>
   </p:extLst>
 </p:presentation>
@@ -169,7 +171,7 @@
           <p:cNvPr id="2" name="頁首版面配置區 1">
             <a:extLst>
               <a:ext uri="{FF2B5EF4-FFF2-40B4-BE49-F238E27FC236}">
-                <a16:creationId xmlns:a16="http://schemas.microsoft.com/office/drawing/2014/main" xmlns="" id="{FD7239F7-48BE-4033-9139-71B833CE7B15}"/>
+                <a16:creationId xmlns="" xmlns:a16="http://schemas.microsoft.com/office/drawing/2014/main" id="{FD7239F7-48BE-4033-9139-71B833CE7B15}"/>
               </a:ext>
             </a:extLst>
           </p:cNvPr>
@@ -206,7 +208,7 @@
           <p:cNvPr id="3" name="日期版面配置區 2">
             <a:extLst>
               <a:ext uri="{FF2B5EF4-FFF2-40B4-BE49-F238E27FC236}">
-                <a16:creationId xmlns:a16="http://schemas.microsoft.com/office/drawing/2014/main" xmlns="" id="{25547E69-A3D0-4645-898C-127D13743B6E}"/>
+                <a16:creationId xmlns="" xmlns:a16="http://schemas.microsoft.com/office/drawing/2014/main" id="{25547E69-A3D0-4645-898C-127D13743B6E}"/>
               </a:ext>
             </a:extLst>
           </p:cNvPr>
@@ -236,7 +238,7 @@
           <a:p>
             <a:fld id="{4317C7B4-AB09-4FBD-90D9-AEEE416DED9E}" type="datetimeFigureOut">
               <a:rPr lang="zh-TW" altLang="en-US" smtClean="0"/>
-              <a:t>2025/12/30</a:t>
+              <a:t>2026/6/16</a:t>
             </a:fld>
             <a:endParaRPr lang="zh-TW" altLang="en-US"/>
           </a:p>
@@ -247,7 +249,7 @@
           <p:cNvPr id="4" name="頁尾版面配置區 3">
             <a:extLst>
               <a:ext uri="{FF2B5EF4-FFF2-40B4-BE49-F238E27FC236}">
-                <a16:creationId xmlns:a16="http://schemas.microsoft.com/office/drawing/2014/main" xmlns="" id="{C92BD882-4BE9-4A45-8E16-878BAFB6968D}"/>
+                <a16:creationId xmlns="" xmlns:a16="http://schemas.microsoft.com/office/drawing/2014/main" id="{C92BD882-4BE9-4A45-8E16-878BAFB6968D}"/>
               </a:ext>
             </a:extLst>
           </p:cNvPr>
@@ -284,7 +286,7 @@
           <p:cNvPr id="5" name="投影片編號版面配置區 4">
             <a:extLst>
               <a:ext uri="{FF2B5EF4-FFF2-40B4-BE49-F238E27FC236}">
-                <a16:creationId xmlns:a16="http://schemas.microsoft.com/office/drawing/2014/main" xmlns="" id="{FE470A4A-E0BC-49F0-9517-53D70AE09BD1}"/>
+                <a16:creationId xmlns="" xmlns:a16="http://schemas.microsoft.com/office/drawing/2014/main" id="{FE470A4A-E0BC-49F0-9517-53D70AE09BD1}"/>
               </a:ext>
             </a:extLst>
           </p:cNvPr>
@@ -413,7 +415,7 @@
           <a:p>
             <a:fld id="{22F82E8D-725E-458B-A09B-99A6C25447E6}" type="datetimeFigureOut">
               <a:rPr lang="zh-TW" altLang="en-US" smtClean="0"/>
-              <a:t>2025/12/30</a:t>
+              <a:t>2026/6/16</a:t>
             </a:fld>
             <a:endParaRPr lang="zh-TW" altLang="en-US"/>
           </a:p>
@@ -884,7 +886,7 @@
             <a:fld id="{F4A073C8-56C6-2B4A-AD47-1720B2EB1AE9}" type="datetimeFigureOut">
               <a:rPr lang="en-US" smtClean="0"/>
               <a:pPr/>
-              <a:t>12/30/2025</a:t>
+              <a:t>6/16/2026</a:t>
             </a:fld>
             <a:endParaRPr lang="en-US" dirty="0"/>
           </a:p>
@@ -1118,7 +1120,7 @@
             <a:fld id="{F4A073C8-56C6-2B4A-AD47-1720B2EB1AE9}" type="datetimeFigureOut">
               <a:rPr lang="en-US" smtClean="0"/>
               <a:pPr/>
-              <a:t>12/30/2025</a:t>
+              <a:t>6/16/2026</a:t>
             </a:fld>
             <a:endParaRPr lang="en-US" dirty="0"/>
           </a:p>
@@ -1449,7 +1451,7 @@
             <a:fld id="{F4A073C8-56C6-2B4A-AD47-1720B2EB1AE9}" type="datetimeFigureOut">
               <a:rPr lang="en-US" smtClean="0"/>
               <a:pPr/>
-              <a:t>12/30/2025</a:t>
+              <a:t>6/16/2026</a:t>
             </a:fld>
             <a:endParaRPr lang="en-US" dirty="0"/>
           </a:p>
@@ -1867,7 +1869,7 @@
           <p:cNvPr id="3" name="Picture 4">
             <a:extLst>
               <a:ext uri="{FF2B5EF4-FFF2-40B4-BE49-F238E27FC236}">
-                <a16:creationId xmlns:a16="http://schemas.microsoft.com/office/drawing/2014/main" xmlns="" id="{40D466DF-4BD8-4868-A9AD-0E89C717AD41}"/>
+                <a16:creationId xmlns="" xmlns:a16="http://schemas.microsoft.com/office/drawing/2014/main" id="{40D466DF-4BD8-4868-A9AD-0E89C717AD41}"/>
               </a:ext>
             </a:extLst>
           </p:cNvPr>
@@ -2190,7 +2192,7 @@
           <p:cNvPr id="3" name="Picture 2">
             <a:extLst>
               <a:ext uri="{FF2B5EF4-FFF2-40B4-BE49-F238E27FC236}">
-                <a16:creationId xmlns:a16="http://schemas.microsoft.com/office/drawing/2014/main" xmlns="" id="{AAE26669-12ED-429A-B2E1-266CD3186420}"/>
+                <a16:creationId xmlns="" xmlns:a16="http://schemas.microsoft.com/office/drawing/2014/main" id="{AAE26669-12ED-429A-B2E1-266CD3186420}"/>
               </a:ext>
             </a:extLst>
           </p:cNvPr>
@@ -4198,14 +4200,63 @@
           <a:chExt cx="0" cy="0"/>
         </a:xfrm>
       </p:grpSpPr>
+    </p:spTree>
+    <p:extLst>
+      <p:ext uri="{BB962C8B-B14F-4D97-AF65-F5344CB8AC3E}">
+        <p14:creationId xmlns:p14="http://schemas.microsoft.com/office/powerpoint/2010/main" val="2427004046"/>
+      </p:ext>
+    </p:extLst>
+  </p:cSld>
+  <p:clrMapOvr>
+    <a:masterClrMapping/>
+  </p:clrMapOvr>
+</p:sld>
+</file>
+
+<file path=ppt/slides/slide2.xml><?xml version="1.0" encoding="utf-8"?>
+<p:sld xmlns:a="http://schemas.openxmlformats.org/drawingml/2006/main" xmlns:r="http://schemas.openxmlformats.org/officeDocument/2006/relationships" xmlns:p="http://schemas.openxmlformats.org/presentationml/2006/main">
+  <p:cSld>
+    <p:spTree>
+      <p:nvGrpSpPr>
+        <p:cNvPr id="1" name=""/>
+        <p:cNvGrpSpPr/>
+        <p:nvPr/>
+      </p:nvGrpSpPr>
+      <p:grpSpPr>
+        <a:xfrm>
+          <a:off x="0" y="0"/>
+          <a:ext cx="0" cy="0"/>
+          <a:chOff x="0" y="0"/>
+          <a:chExt cx="0" cy="0"/>
+        </a:xfrm>
+      </p:grpSpPr>
       <p:sp>
         <p:nvSpPr>
-          <p:cNvPr id="2" name="標題 1"/>
+          <p:cNvPr id="3" name="標題 2"/>
           <p:cNvSpPr>
             <a:spLocks noGrp="1"/>
           </p:cNvSpPr>
           <p:nvPr>
-            <p:ph type="title"/>
+            <p:ph type="ctrTitle"/>
+          </p:nvPr>
+        </p:nvSpPr>
+        <p:spPr/>
+        <p:txBody>
+          <a:bodyPr/>
+          <a:lstStyle/>
+          <a:p>
+            <a:endParaRPr lang="zh-TW" altLang="en-US"/>
+          </a:p>
+        </p:txBody>
+      </p:sp>
+      <p:sp>
+        <p:nvSpPr>
+          <p:cNvPr id="4" name="副標題 3"/>
+          <p:cNvSpPr>
+            <a:spLocks noGrp="1"/>
+          </p:cNvSpPr>
+          <p:nvPr>
+            <p:ph type="subTitle" idx="1"/>
           </p:nvPr>
         </p:nvSpPr>
         <p:spPr/>
@@ -4234,6 +4285,74 @@
       </p:par>
     </p:tnLst>
   </p:timing>
+</p:sld>
+</file>
+
+<file path=ppt/slides/slide3.xml><?xml version="1.0" encoding="utf-8"?>
+<p:sld xmlns:a="http://schemas.openxmlformats.org/drawingml/2006/main" xmlns:r="http://schemas.openxmlformats.org/officeDocument/2006/relationships" xmlns:p="http://schemas.openxmlformats.org/presentationml/2006/main">
+  <p:cSld>
+    <p:spTree>
+      <p:nvGrpSpPr>
+        <p:cNvPr id="1" name=""/>
+        <p:cNvGrpSpPr/>
+        <p:nvPr/>
+      </p:nvGrpSpPr>
+      <p:grpSpPr>
+        <a:xfrm>
+          <a:off x="0" y="0"/>
+          <a:ext cx="0" cy="0"/>
+          <a:chOff x="0" y="0"/>
+          <a:chExt cx="0" cy="0"/>
+        </a:xfrm>
+      </p:grpSpPr>
+      <p:sp>
+        <p:nvSpPr>
+          <p:cNvPr id="2" name="標題 1"/>
+          <p:cNvSpPr>
+            <a:spLocks noGrp="1"/>
+          </p:cNvSpPr>
+          <p:nvPr>
+            <p:ph type="title"/>
+          </p:nvPr>
+        </p:nvSpPr>
+        <p:spPr/>
+        <p:txBody>
+          <a:bodyPr/>
+          <a:lstStyle/>
+          <a:p>
+            <a:endParaRPr lang="zh-TW" altLang="en-US"/>
+          </a:p>
+        </p:txBody>
+      </p:sp>
+      <p:sp>
+        <p:nvSpPr>
+          <p:cNvPr id="3" name="內容版面配置區 2"/>
+          <p:cNvSpPr>
+            <a:spLocks noGrp="1"/>
+          </p:cNvSpPr>
+          <p:nvPr>
+            <p:ph idx="1"/>
+          </p:nvPr>
+        </p:nvSpPr>
+        <p:spPr/>
+        <p:txBody>
+          <a:bodyPr/>
+          <a:lstStyle/>
+          <a:p>
+            <a:endParaRPr lang="zh-TW" altLang="en-US"/>
+          </a:p>
+        </p:txBody>
+      </p:sp>
+    </p:spTree>
+    <p:extLst>
+      <p:ext uri="{BB962C8B-B14F-4D97-AF65-F5344CB8AC3E}">
+        <p14:creationId xmlns:p14="http://schemas.microsoft.com/office/powerpoint/2010/main" val="3531627541"/>
+      </p:ext>
+    </p:extLst>
+  </p:cSld>
+  <p:clrMapOvr>
+    <a:masterClrMapping/>
+  </p:clrMapOvr>
 </p:sld>
 </file>
 
@@ -4492,7 +4611,7 @@
   <a:extraClrSchemeLst/>
   <a:extLst>
     <a:ext uri="{05A4C25C-085E-4340-85A3-A5531E510DB2}">
-      <thm15:themeFamily xmlns:thm15="http://schemas.microsoft.com/office/thememl/2012/main" xmlns="" name="Office Theme" id="{62F939B6-93AF-4DB8-9C6B-D6C7DFDC589F}" vid="{4A3C46E8-61CC-4603-A589-7422A47A8E4A}"/>
+      <thm15:themeFamily xmlns="" xmlns:thm15="http://schemas.microsoft.com/office/thememl/2012/main" name="Office Theme" id="{62F939B6-93AF-4DB8-9C6B-D6C7DFDC589F}" vid="{4A3C46E8-61CC-4603-A589-7422A47A8E4A}"/>
     </a:ext>
   </a:extLst>
 </a:theme>
@@ -5072,7 +5191,7 @@
   <a:extraClrSchemeLst/>
   <a:extLst>
     <a:ext uri="{05A4C25C-085E-4340-85A3-A5531E510DB2}">
-      <thm15:themeFamily xmlns:thm15="http://schemas.microsoft.com/office/thememl/2012/main" xmlns="" name="Office Theme" id="{62F939B6-93AF-4DB8-9C6B-D6C7DFDC589F}" vid="{4A3C46E8-61CC-4603-A589-7422A47A8E4A}"/>
+      <thm15:themeFamily xmlns="" xmlns:thm15="http://schemas.microsoft.com/office/thememl/2012/main" name="Office Theme" id="{62F939B6-93AF-4DB8-9C6B-D6C7DFDC589F}" vid="{4A3C46E8-61CC-4603-A589-7422A47A8E4A}"/>
     </a:ext>
   </a:extLst>
 </a:theme>

</xml_diff>